<commit_message>
Update polished presentation deck
</commit_message>
<xml_diff>
--- a/resume_jd_matching_presentation.pptx
+++ b/resume_jd_matching_presentation.pptx
@@ -5,18 +5,14 @@
     <p:sldMasterId id="2147483648" r:id="rId1"/>
   </p:sldMasterIdLst>
   <p:sldIdLst>
-    <p:sldId id="256" r:id="rId7"/>
-    <p:sldId id="257" r:id="rId8"/>
-    <p:sldId id="258" r:id="rId9"/>
-    <p:sldId id="259" r:id="rId10"/>
-    <p:sldId id="260" r:id="rId11"/>
-    <p:sldId id="261" r:id="rId12"/>
-    <p:sldId id="262" r:id="rId13"/>
-    <p:sldId id="263" r:id="rId14"/>
-    <p:sldId id="264" r:id="rId15"/>
-    <p:sldId id="265" r:id="rId16"/>
-    <p:sldId id="266" r:id="rId17"/>
-    <p:sldId id="267" r:id="rId18"/>
+    <p:sldId id="256" r:id="rId2"/>
+    <p:sldId id="257" r:id="rId3"/>
+    <p:sldId id="258" r:id="rId4"/>
+    <p:sldId id="259" r:id="rId5"/>
+    <p:sldId id="260" r:id="rId6"/>
+    <p:sldId id="261" r:id="rId7"/>
+    <p:sldId id="262" r:id="rId8"/>
+    <p:sldId id="263" r:id="rId9"/>
   </p:sldIdLst>
   <p:sldSz cx="9144000" cy="6858000" type="screen4x3"/>
   <p:notesSz cx="6858000" cy="9144000"/>
@@ -115,6 +111,22 @@
       </a:defRPr>
     </a:lvl9pPr>
   </p:defaultTextStyle>
+  <p:extLst>
+    <p:ext uri="{EFAFB233-063F-42B5-8137-9DF3F51BA10A}">
+      <p15:sldGuideLst xmlns:p15="http://schemas.microsoft.com/office/powerpoint/2012/main">
+        <p15:guide id="1" orient="horz" pos="2160">
+          <p15:clr>
+            <a:srgbClr val="A4A3A4"/>
+          </p15:clr>
+        </p15:guide>
+        <p15:guide id="2" pos="2880">
+          <p15:clr>
+            <a:srgbClr val="A4A3A4"/>
+          </p15:clr>
+        </p15:guide>
+      </p15:sldGuideLst>
+    </p:ext>
+  </p:extLst>
 </p:presentation>
 </file>
 
@@ -156,10 +168,9 @@
           <a:lstStyle/>
           <a:p>
             <a:r>
-              <a:rPr lang="en-US" smtClean="0"/>
+              <a:rPr lang="en-US"/>
               <a:t>Click to edit Master title style</a:t>
             </a:r>
-            <a:endParaRPr lang="en-US"/>
           </a:p>
         </p:txBody>
       </p:sp>
@@ -275,10 +286,9 @@
           </a:lstStyle>
           <a:p>
             <a:r>
-              <a:rPr lang="en-US" smtClean="0"/>
+              <a:rPr lang="en-US"/>
               <a:t>Click to edit Master subtitle style</a:t>
             </a:r>
-            <a:endParaRPr lang="en-US"/>
           </a:p>
         </p:txBody>
       </p:sp>
@@ -299,7 +309,7 @@
           <a:p>
             <a:fld id="{5BCAD085-E8A6-8845-BD4E-CB4CCA059FC4}" type="datetimeFigureOut">
               <a:rPr lang="en-US" smtClean="0"/>
-              <a:t>1/27/13</a:t>
+              <a:t>6/25/2026</a:t>
             </a:fld>
             <a:endParaRPr lang="en-US"/>
           </a:p>
@@ -393,10 +403,9 @@
           <a:lstStyle/>
           <a:p>
             <a:r>
-              <a:rPr lang="en-US" smtClean="0"/>
+              <a:rPr lang="en-US"/>
               <a:t>Click to edit Master title style</a:t>
             </a:r>
-            <a:endParaRPr lang="en-US"/>
           </a:p>
         </p:txBody>
       </p:sp>
@@ -417,38 +426,37 @@
           <a:p>
             <a:pPr lvl="0"/>
             <a:r>
-              <a:rPr lang="en-US" smtClean="0"/>
+              <a:rPr lang="en-US"/>
               <a:t>Click to edit Master text styles</a:t>
             </a:r>
           </a:p>
           <a:p>
             <a:pPr lvl="1"/>
             <a:r>
-              <a:rPr lang="en-US" smtClean="0"/>
+              <a:rPr lang="en-US"/>
               <a:t>Second level</a:t>
             </a:r>
           </a:p>
           <a:p>
             <a:pPr lvl="2"/>
             <a:r>
-              <a:rPr lang="en-US" smtClean="0"/>
+              <a:rPr lang="en-US"/>
               <a:t>Third level</a:t>
             </a:r>
           </a:p>
           <a:p>
             <a:pPr lvl="3"/>
             <a:r>
-              <a:rPr lang="en-US" smtClean="0"/>
+              <a:rPr lang="en-US"/>
               <a:t>Fourth level</a:t>
             </a:r>
           </a:p>
           <a:p>
             <a:pPr lvl="4"/>
             <a:r>
-              <a:rPr lang="en-US" smtClean="0"/>
+              <a:rPr lang="en-US"/>
               <a:t>Fifth level</a:t>
             </a:r>
-            <a:endParaRPr lang="en-US"/>
           </a:p>
         </p:txBody>
       </p:sp>
@@ -469,7 +477,7 @@
           <a:p>
             <a:fld id="{5BCAD085-E8A6-8845-BD4E-CB4CCA059FC4}" type="datetimeFigureOut">
               <a:rPr lang="en-US" smtClean="0"/>
-              <a:t>1/27/13</a:t>
+              <a:t>6/25/2026</a:t>
             </a:fld>
             <a:endParaRPr lang="en-US"/>
           </a:p>
@@ -568,10 +576,9 @@
           <a:lstStyle/>
           <a:p>
             <a:r>
-              <a:rPr lang="en-US" smtClean="0"/>
+              <a:rPr lang="en-US"/>
               <a:t>Click to edit Master title style</a:t>
             </a:r>
-            <a:endParaRPr lang="en-US"/>
           </a:p>
         </p:txBody>
       </p:sp>
@@ -597,38 +604,37 @@
           <a:p>
             <a:pPr lvl="0"/>
             <a:r>
-              <a:rPr lang="en-US" smtClean="0"/>
+              <a:rPr lang="en-US"/>
               <a:t>Click to edit Master text styles</a:t>
             </a:r>
           </a:p>
           <a:p>
             <a:pPr lvl="1"/>
             <a:r>
-              <a:rPr lang="en-US" smtClean="0"/>
+              <a:rPr lang="en-US"/>
               <a:t>Second level</a:t>
             </a:r>
           </a:p>
           <a:p>
             <a:pPr lvl="2"/>
             <a:r>
-              <a:rPr lang="en-US" smtClean="0"/>
+              <a:rPr lang="en-US"/>
               <a:t>Third level</a:t>
             </a:r>
           </a:p>
           <a:p>
             <a:pPr lvl="3"/>
             <a:r>
-              <a:rPr lang="en-US" smtClean="0"/>
+              <a:rPr lang="en-US"/>
               <a:t>Fourth level</a:t>
             </a:r>
           </a:p>
           <a:p>
             <a:pPr lvl="4"/>
             <a:r>
-              <a:rPr lang="en-US" smtClean="0"/>
+              <a:rPr lang="en-US"/>
               <a:t>Fifth level</a:t>
             </a:r>
-            <a:endParaRPr lang="en-US"/>
           </a:p>
         </p:txBody>
       </p:sp>
@@ -649,7 +655,7 @@
           <a:p>
             <a:fld id="{5BCAD085-E8A6-8845-BD4E-CB4CCA059FC4}" type="datetimeFigureOut">
               <a:rPr lang="en-US" smtClean="0"/>
-              <a:t>1/27/13</a:t>
+              <a:t>6/25/2026</a:t>
             </a:fld>
             <a:endParaRPr lang="en-US"/>
           </a:p>
@@ -743,10 +749,9 @@
           <a:lstStyle/>
           <a:p>
             <a:r>
-              <a:rPr lang="en-US" smtClean="0"/>
+              <a:rPr lang="en-US"/>
               <a:t>Click to edit Master title style</a:t>
             </a:r>
-            <a:endParaRPr lang="en-US"/>
           </a:p>
         </p:txBody>
       </p:sp>
@@ -767,38 +772,37 @@
           <a:p>
             <a:pPr lvl="0"/>
             <a:r>
-              <a:rPr lang="en-US" smtClean="0"/>
+              <a:rPr lang="en-US"/>
               <a:t>Click to edit Master text styles</a:t>
             </a:r>
           </a:p>
           <a:p>
             <a:pPr lvl="1"/>
             <a:r>
-              <a:rPr lang="en-US" smtClean="0"/>
+              <a:rPr lang="en-US"/>
               <a:t>Second level</a:t>
             </a:r>
           </a:p>
           <a:p>
             <a:pPr lvl="2"/>
             <a:r>
-              <a:rPr lang="en-US" smtClean="0"/>
+              <a:rPr lang="en-US"/>
               <a:t>Third level</a:t>
             </a:r>
           </a:p>
           <a:p>
             <a:pPr lvl="3"/>
             <a:r>
-              <a:rPr lang="en-US" smtClean="0"/>
+              <a:rPr lang="en-US"/>
               <a:t>Fourth level</a:t>
             </a:r>
           </a:p>
           <a:p>
             <a:pPr lvl="4"/>
             <a:r>
-              <a:rPr lang="en-US" smtClean="0"/>
+              <a:rPr lang="en-US"/>
               <a:t>Fifth level</a:t>
             </a:r>
-            <a:endParaRPr lang="en-US"/>
           </a:p>
         </p:txBody>
       </p:sp>
@@ -819,7 +823,7 @@
           <a:p>
             <a:fld id="{5BCAD085-E8A6-8845-BD4E-CB4CCA059FC4}" type="datetimeFigureOut">
               <a:rPr lang="en-US" smtClean="0"/>
-              <a:t>1/27/13</a:t>
+              <a:t>6/25/2026</a:t>
             </a:fld>
             <a:endParaRPr lang="en-US"/>
           </a:p>
@@ -922,10 +926,9 @@
           </a:lstStyle>
           <a:p>
             <a:r>
-              <a:rPr lang="en-US" smtClean="0"/>
+              <a:rPr lang="en-US"/>
               <a:t>Click to edit Master title style</a:t>
             </a:r>
-            <a:endParaRPr lang="en-US"/>
           </a:p>
         </p:txBody>
       </p:sp>
@@ -1042,7 +1045,7 @@
           <a:p>
             <a:pPr lvl="0"/>
             <a:r>
-              <a:rPr lang="en-US" smtClean="0"/>
+              <a:rPr lang="en-US"/>
               <a:t>Click to edit Master text styles</a:t>
             </a:r>
           </a:p>
@@ -1065,7 +1068,7 @@
           <a:p>
             <a:fld id="{5BCAD085-E8A6-8845-BD4E-CB4CCA059FC4}" type="datetimeFigureOut">
               <a:rPr lang="en-US" smtClean="0"/>
-              <a:t>1/27/13</a:t>
+              <a:t>6/25/2026</a:t>
             </a:fld>
             <a:endParaRPr lang="en-US"/>
           </a:p>
@@ -1159,10 +1162,9 @@
           <a:lstStyle/>
           <a:p>
             <a:r>
-              <a:rPr lang="en-US" smtClean="0"/>
+              <a:rPr lang="en-US"/>
               <a:t>Click to edit Master title style</a:t>
             </a:r>
-            <a:endParaRPr lang="en-US"/>
           </a:p>
         </p:txBody>
       </p:sp>
@@ -1216,38 +1218,37 @@
           <a:p>
             <a:pPr lvl="0"/>
             <a:r>
-              <a:rPr lang="en-US" smtClean="0"/>
+              <a:rPr lang="en-US"/>
               <a:t>Click to edit Master text styles</a:t>
             </a:r>
           </a:p>
           <a:p>
             <a:pPr lvl="1"/>
             <a:r>
-              <a:rPr lang="en-US" smtClean="0"/>
+              <a:rPr lang="en-US"/>
               <a:t>Second level</a:t>
             </a:r>
           </a:p>
           <a:p>
             <a:pPr lvl="2"/>
             <a:r>
-              <a:rPr lang="en-US" smtClean="0"/>
+              <a:rPr lang="en-US"/>
               <a:t>Third level</a:t>
             </a:r>
           </a:p>
           <a:p>
             <a:pPr lvl="3"/>
             <a:r>
-              <a:rPr lang="en-US" smtClean="0"/>
+              <a:rPr lang="en-US"/>
               <a:t>Fourth level</a:t>
             </a:r>
           </a:p>
           <a:p>
             <a:pPr lvl="4"/>
             <a:r>
-              <a:rPr lang="en-US" smtClean="0"/>
+              <a:rPr lang="en-US"/>
               <a:t>Fifth level</a:t>
             </a:r>
-            <a:endParaRPr lang="en-US"/>
           </a:p>
         </p:txBody>
       </p:sp>
@@ -1301,38 +1302,37 @@
           <a:p>
             <a:pPr lvl="0"/>
             <a:r>
-              <a:rPr lang="en-US" smtClean="0"/>
+              <a:rPr lang="en-US"/>
               <a:t>Click to edit Master text styles</a:t>
             </a:r>
           </a:p>
           <a:p>
             <a:pPr lvl="1"/>
             <a:r>
-              <a:rPr lang="en-US" smtClean="0"/>
+              <a:rPr lang="en-US"/>
               <a:t>Second level</a:t>
             </a:r>
           </a:p>
           <a:p>
             <a:pPr lvl="2"/>
             <a:r>
-              <a:rPr lang="en-US" smtClean="0"/>
+              <a:rPr lang="en-US"/>
               <a:t>Third level</a:t>
             </a:r>
           </a:p>
           <a:p>
             <a:pPr lvl="3"/>
             <a:r>
-              <a:rPr lang="en-US" smtClean="0"/>
+              <a:rPr lang="en-US"/>
               <a:t>Fourth level</a:t>
             </a:r>
           </a:p>
           <a:p>
             <a:pPr lvl="4"/>
             <a:r>
-              <a:rPr lang="en-US" smtClean="0"/>
+              <a:rPr lang="en-US"/>
               <a:t>Fifth level</a:t>
             </a:r>
-            <a:endParaRPr lang="en-US"/>
           </a:p>
         </p:txBody>
       </p:sp>
@@ -1353,7 +1353,7 @@
           <a:p>
             <a:fld id="{5BCAD085-E8A6-8845-BD4E-CB4CCA059FC4}" type="datetimeFigureOut">
               <a:rPr lang="en-US" smtClean="0"/>
-              <a:t>1/27/13</a:t>
+              <a:t>6/25/2026</a:t>
             </a:fld>
             <a:endParaRPr lang="en-US"/>
           </a:p>
@@ -1451,10 +1451,9 @@
           </a:lstStyle>
           <a:p>
             <a:r>
-              <a:rPr lang="en-US" smtClean="0"/>
+              <a:rPr lang="en-US"/>
               <a:t>Click to edit Master title style</a:t>
             </a:r>
-            <a:endParaRPr lang="en-US"/>
           </a:p>
         </p:txBody>
       </p:sp>
@@ -1517,7 +1516,7 @@
           <a:p>
             <a:pPr lvl="0"/>
             <a:r>
-              <a:rPr lang="en-US" smtClean="0"/>
+              <a:rPr lang="en-US"/>
               <a:t>Click to edit Master text styles</a:t>
             </a:r>
           </a:p>
@@ -1573,38 +1572,37 @@
           <a:p>
             <a:pPr lvl="0"/>
             <a:r>
-              <a:rPr lang="en-US" smtClean="0"/>
+              <a:rPr lang="en-US"/>
               <a:t>Click to edit Master text styles</a:t>
             </a:r>
           </a:p>
           <a:p>
             <a:pPr lvl="1"/>
             <a:r>
-              <a:rPr lang="en-US" smtClean="0"/>
+              <a:rPr lang="en-US"/>
               <a:t>Second level</a:t>
             </a:r>
           </a:p>
           <a:p>
             <a:pPr lvl="2"/>
             <a:r>
-              <a:rPr lang="en-US" smtClean="0"/>
+              <a:rPr lang="en-US"/>
               <a:t>Third level</a:t>
             </a:r>
           </a:p>
           <a:p>
             <a:pPr lvl="3"/>
             <a:r>
-              <a:rPr lang="en-US" smtClean="0"/>
+              <a:rPr lang="en-US"/>
               <a:t>Fourth level</a:t>
             </a:r>
           </a:p>
           <a:p>
             <a:pPr lvl="4"/>
             <a:r>
-              <a:rPr lang="en-US" smtClean="0"/>
+              <a:rPr lang="en-US"/>
               <a:t>Fifth level</a:t>
             </a:r>
-            <a:endParaRPr lang="en-US"/>
           </a:p>
         </p:txBody>
       </p:sp>
@@ -1667,7 +1665,7 @@
           <a:p>
             <a:pPr lvl="0"/>
             <a:r>
-              <a:rPr lang="en-US" smtClean="0"/>
+              <a:rPr lang="en-US"/>
               <a:t>Click to edit Master text styles</a:t>
             </a:r>
           </a:p>
@@ -1723,38 +1721,37 @@
           <a:p>
             <a:pPr lvl="0"/>
             <a:r>
-              <a:rPr lang="en-US" smtClean="0"/>
+              <a:rPr lang="en-US"/>
               <a:t>Click to edit Master text styles</a:t>
             </a:r>
           </a:p>
           <a:p>
             <a:pPr lvl="1"/>
             <a:r>
-              <a:rPr lang="en-US" smtClean="0"/>
+              <a:rPr lang="en-US"/>
               <a:t>Second level</a:t>
             </a:r>
           </a:p>
           <a:p>
             <a:pPr lvl="2"/>
             <a:r>
-              <a:rPr lang="en-US" smtClean="0"/>
+              <a:rPr lang="en-US"/>
               <a:t>Third level</a:t>
             </a:r>
           </a:p>
           <a:p>
             <a:pPr lvl="3"/>
             <a:r>
-              <a:rPr lang="en-US" smtClean="0"/>
+              <a:rPr lang="en-US"/>
               <a:t>Fourth level</a:t>
             </a:r>
           </a:p>
           <a:p>
             <a:pPr lvl="4"/>
             <a:r>
-              <a:rPr lang="en-US" smtClean="0"/>
+              <a:rPr lang="en-US"/>
               <a:t>Fifth level</a:t>
             </a:r>
-            <a:endParaRPr lang="en-US"/>
           </a:p>
         </p:txBody>
       </p:sp>
@@ -1775,7 +1772,7 @@
           <a:p>
             <a:fld id="{5BCAD085-E8A6-8845-BD4E-CB4CCA059FC4}" type="datetimeFigureOut">
               <a:rPr lang="en-US" smtClean="0"/>
-              <a:t>1/27/13</a:t>
+              <a:t>6/25/2026</a:t>
             </a:fld>
             <a:endParaRPr lang="en-US"/>
           </a:p>
@@ -1869,10 +1866,9 @@
           <a:lstStyle/>
           <a:p>
             <a:r>
-              <a:rPr lang="en-US" smtClean="0"/>
+              <a:rPr lang="en-US"/>
               <a:t>Click to edit Master title style</a:t>
             </a:r>
-            <a:endParaRPr lang="en-US"/>
           </a:p>
         </p:txBody>
       </p:sp>
@@ -1893,7 +1889,7 @@
           <a:p>
             <a:fld id="{5BCAD085-E8A6-8845-BD4E-CB4CCA059FC4}" type="datetimeFigureOut">
               <a:rPr lang="en-US" smtClean="0"/>
-              <a:t>1/27/13</a:t>
+              <a:t>6/25/2026</a:t>
             </a:fld>
             <a:endParaRPr lang="en-US"/>
           </a:p>
@@ -1988,7 +1984,7 @@
           <a:p>
             <a:fld id="{5BCAD085-E8A6-8845-BD4E-CB4CCA059FC4}" type="datetimeFigureOut">
               <a:rPr lang="en-US" smtClean="0"/>
-              <a:t>1/27/13</a:t>
+              <a:t>6/25/2026</a:t>
             </a:fld>
             <a:endParaRPr lang="en-US"/>
           </a:p>
@@ -2091,10 +2087,9 @@
           </a:lstStyle>
           <a:p>
             <a:r>
-              <a:rPr lang="en-US" smtClean="0"/>
+              <a:rPr lang="en-US"/>
               <a:t>Click to edit Master title style</a:t>
             </a:r>
-            <a:endParaRPr lang="en-US"/>
           </a:p>
         </p:txBody>
       </p:sp>
@@ -2148,38 +2143,37 @@
           <a:p>
             <a:pPr lvl="0"/>
             <a:r>
-              <a:rPr lang="en-US" smtClean="0"/>
+              <a:rPr lang="en-US"/>
               <a:t>Click to edit Master text styles</a:t>
             </a:r>
           </a:p>
           <a:p>
             <a:pPr lvl="1"/>
             <a:r>
-              <a:rPr lang="en-US" smtClean="0"/>
+              <a:rPr lang="en-US"/>
               <a:t>Second level</a:t>
             </a:r>
           </a:p>
           <a:p>
             <a:pPr lvl="2"/>
             <a:r>
-              <a:rPr lang="en-US" smtClean="0"/>
+              <a:rPr lang="en-US"/>
               <a:t>Third level</a:t>
             </a:r>
           </a:p>
           <a:p>
             <a:pPr lvl="3"/>
             <a:r>
-              <a:rPr lang="en-US" smtClean="0"/>
+              <a:rPr lang="en-US"/>
               <a:t>Fourth level</a:t>
             </a:r>
           </a:p>
           <a:p>
             <a:pPr lvl="4"/>
             <a:r>
-              <a:rPr lang="en-US" smtClean="0"/>
+              <a:rPr lang="en-US"/>
               <a:t>Fifth level</a:t>
             </a:r>
-            <a:endParaRPr lang="en-US"/>
           </a:p>
         </p:txBody>
       </p:sp>
@@ -2242,7 +2236,7 @@
           <a:p>
             <a:pPr lvl="0"/>
             <a:r>
-              <a:rPr lang="en-US" smtClean="0"/>
+              <a:rPr lang="en-US"/>
               <a:t>Click to edit Master text styles</a:t>
             </a:r>
           </a:p>
@@ -2265,7 +2259,7 @@
           <a:p>
             <a:fld id="{5BCAD085-E8A6-8845-BD4E-CB4CCA059FC4}" type="datetimeFigureOut">
               <a:rPr lang="en-US" smtClean="0"/>
-              <a:t>1/27/13</a:t>
+              <a:t>6/25/2026</a:t>
             </a:fld>
             <a:endParaRPr lang="en-US"/>
           </a:p>
@@ -2368,10 +2362,9 @@
           </a:lstStyle>
           <a:p>
             <a:r>
-              <a:rPr lang="en-US" smtClean="0"/>
+              <a:rPr lang="en-US"/>
               <a:t>Click to edit Master title style</a:t>
             </a:r>
-            <a:endParaRPr lang="en-US"/>
           </a:p>
         </p:txBody>
       </p:sp>
@@ -2495,7 +2488,7 @@
           <a:p>
             <a:pPr lvl="0"/>
             <a:r>
-              <a:rPr lang="en-US" smtClean="0"/>
+              <a:rPr lang="en-US"/>
               <a:t>Click to edit Master text styles</a:t>
             </a:r>
           </a:p>
@@ -2518,7 +2511,7 @@
           <a:p>
             <a:fld id="{5BCAD085-E8A6-8845-BD4E-CB4CCA059FC4}" type="datetimeFigureOut">
               <a:rPr lang="en-US" smtClean="0"/>
-              <a:t>1/27/13</a:t>
+              <a:t>6/25/2026</a:t>
             </a:fld>
             <a:endParaRPr lang="en-US"/>
           </a:p>
@@ -2627,10 +2620,9 @@
           <a:lstStyle/>
           <a:p>
             <a:r>
-              <a:rPr lang="en-US" smtClean="0"/>
+              <a:rPr lang="en-US"/>
               <a:t>Click to edit Master title style</a:t>
             </a:r>
-            <a:endParaRPr lang="en-US"/>
           </a:p>
         </p:txBody>
       </p:sp>
@@ -2661,38 +2653,37 @@
           <a:p>
             <a:pPr lvl="0"/>
             <a:r>
-              <a:rPr lang="en-US" smtClean="0"/>
+              <a:rPr lang="en-US"/>
               <a:t>Click to edit Master text styles</a:t>
             </a:r>
           </a:p>
           <a:p>
             <a:pPr lvl="1"/>
             <a:r>
-              <a:rPr lang="en-US" smtClean="0"/>
+              <a:rPr lang="en-US"/>
               <a:t>Second level</a:t>
             </a:r>
           </a:p>
           <a:p>
             <a:pPr lvl="2"/>
             <a:r>
-              <a:rPr lang="en-US" smtClean="0"/>
+              <a:rPr lang="en-US"/>
               <a:t>Third level</a:t>
             </a:r>
           </a:p>
           <a:p>
             <a:pPr lvl="3"/>
             <a:r>
-              <a:rPr lang="en-US" smtClean="0"/>
+              <a:rPr lang="en-US"/>
               <a:t>Fourth level</a:t>
             </a:r>
           </a:p>
           <a:p>
             <a:pPr lvl="4"/>
             <a:r>
-              <a:rPr lang="en-US" smtClean="0"/>
+              <a:rPr lang="en-US"/>
               <a:t>Fifth level</a:t>
             </a:r>
-            <a:endParaRPr lang="en-US"/>
           </a:p>
         </p:txBody>
       </p:sp>
@@ -2731,7 +2722,7 @@
           <a:p>
             <a:fld id="{5BCAD085-E8A6-8845-BD4E-CB4CCA059FC4}" type="datetimeFigureOut">
               <a:rPr lang="en-US" smtClean="0"/>
-              <a:t>1/27/13</a:t>
+              <a:t>6/25/2026</a:t>
             </a:fld>
             <a:endParaRPr lang="en-US"/>
           </a:p>
@@ -3090,30 +3081,59 @@
 </file>
 
 <file path=ppt/slides/slide1.xml><?xml version="1.0" encoding="utf-8"?>
-<p:sld xmlns:a="http://schemas.openxmlformats.org/drawingml/2006/main" xmlns:p="http://schemas.openxmlformats.org/presentationml/2006/main" xmlns:r="http://schemas.openxmlformats.org/officeDocument/2006/relationships">
+<p:sld xmlns:a="http://schemas.openxmlformats.org/drawingml/2006/main" xmlns:r="http://schemas.openxmlformats.org/officeDocument/2006/relationships" xmlns:p="http://schemas.openxmlformats.org/presentationml/2006/main">
   <p:cSld>
+    <p:bg>
+      <p:bgPr>
+        <a:solidFill>
+          <a:srgbClr val="0F204A"/>
+        </a:solidFill>
+        <a:effectLst/>
+      </p:bgPr>
+    </p:bg>
     <p:spTree>
       <p:nvGrpSpPr>
         <p:cNvPr id="1" name=""/>
         <p:cNvGrpSpPr/>
         <p:nvPr/>
       </p:nvGrpSpPr>
-      <p:grpSpPr/>
-      <p:sp>
-        <p:nvSpPr>
-          <p:cNvPr id="2" name="Title 1"/>
-          <p:cNvSpPr>
-            <a:spLocks noGrp="1"/>
-          </p:cNvSpPr>
-          <p:nvPr>
-            <p:ph type="title"/>
-          </p:nvPr>
-        </p:nvSpPr>
-        <p:spPr/>
-        <p:txBody>
-          <a:bodyPr/>
-          <a:lstStyle/>
-          <a:p>
+      <p:grpSpPr>
+        <a:xfrm>
+          <a:off x="0" y="0"/>
+          <a:ext cx="0" cy="0"/>
+          <a:chOff x="0" y="0"/>
+          <a:chExt cx="0" cy="0"/>
+        </a:xfrm>
+      </p:grpSpPr>
+      <p:sp>
+        <p:nvSpPr>
+          <p:cNvPr id="2" name="TextBox 1"/>
+          <p:cNvSpPr txBox="1"/>
+          <p:nvPr/>
+        </p:nvSpPr>
+        <p:spPr>
+          <a:xfrm>
+            <a:off x="914400" y="1371600"/>
+            <a:ext cx="7315200" cy="1371600"/>
+          </a:xfrm>
+          <a:prstGeom prst="rect">
+            <a:avLst/>
+          </a:prstGeom>
+          <a:noFill/>
+        </p:spPr>
+        <p:txBody>
+          <a:bodyPr wrap="none">
+            <a:spAutoFit/>
+          </a:bodyPr>
+          <a:lstStyle/>
+          <a:p>
+            <a:pPr>
+              <a:defRPr sz="4800" b="1">
+                <a:solidFill>
+                  <a:srgbClr val="FFFFFF"/>
+                </a:solidFill>
+              </a:defRPr>
+            </a:pPr>
             <a:r>
               <a:t>Resume JD Matching System</a:t>
             </a:r>
@@ -3122,42 +3142,115 @@
       </p:sp>
       <p:sp>
         <p:nvSpPr>
-          <p:cNvPr id="3" name="Content Placeholder 2"/>
-          <p:cNvSpPr>
-            <a:spLocks noGrp="1"/>
-          </p:cNvSpPr>
-          <p:nvPr>
-            <p:ph idx="1"/>
-          </p:nvPr>
-        </p:nvSpPr>
-        <p:spPr/>
-        <p:txBody>
-          <a:bodyPr/>
-          <a:lstStyle/>
-          <a:p/>
+          <p:cNvPr id="3" name="TextBox 2"/>
+          <p:cNvSpPr txBox="1"/>
+          <p:nvPr/>
+        </p:nvSpPr>
+        <p:spPr>
+          <a:xfrm>
+            <a:off x="914400" y="2926080"/>
+            <a:ext cx="7315200" cy="914400"/>
+          </a:xfrm>
+          <a:prstGeom prst="rect">
+            <a:avLst/>
+          </a:prstGeom>
+          <a:noFill/>
+        </p:spPr>
+        <p:txBody>
+          <a:bodyPr wrap="none">
+            <a:spAutoFit/>
+          </a:bodyPr>
+          <a:lstStyle/>
           <a:p>
             <a:pPr>
-              <a:defRPr sz="1800"/>
+              <a:defRPr sz="2200">
+                <a:solidFill>
+                  <a:srgbClr val="D7E0FF"/>
+                </a:solidFill>
+              </a:defRPr>
             </a:pPr>
             <a:r>
-              <a:t>AI/ML capstone project for automated resume screening and candidate-job matching.</a:t>
-            </a:r>
-          </a:p>
+              <a:t>AI-powered Candidate Ranking, Skill Gap Analysis, and Recruiter Insights</a:t>
+            </a:r>
+          </a:p>
+        </p:txBody>
+      </p:sp>
+      <p:sp>
+        <p:nvSpPr>
+          <p:cNvPr id="4" name="TextBox 3"/>
+          <p:cNvSpPr txBox="1"/>
+          <p:nvPr/>
+        </p:nvSpPr>
+        <p:spPr>
+          <a:xfrm>
+            <a:off x="914400" y="4754880"/>
+            <a:ext cx="7315200" cy="548640"/>
+          </a:xfrm>
+          <a:prstGeom prst="rect">
+            <a:avLst/>
+          </a:prstGeom>
+          <a:noFill/>
+        </p:spPr>
+        <p:txBody>
+          <a:bodyPr wrap="none">
+            <a:spAutoFit/>
+          </a:bodyPr>
+          <a:lstStyle/>
           <a:p>
             <a:pPr>
-              <a:defRPr sz="1800"/>
+              <a:defRPr sz="1400">
+                <a:solidFill>
+                  <a:srgbClr val="AFBEFF"/>
+                </a:solidFill>
+              </a:defRPr>
             </a:pPr>
             <a:r>
-              <a:t>Domain: HR Tech / NLP</a:t>
-            </a:r>
-          </a:p>
-          <a:p>
-            <a:pPr>
-              <a:defRPr sz="1800"/>
-            </a:pPr>
-            <a:r>
-              <a:t>Prototype: Streamlit dashboard + trained model artifacts</a:t>
-            </a:r>
+              <a:t>Streamlit Demo · SBERT Embeddings · XGBoost · HR Tech</a:t>
+            </a:r>
+          </a:p>
+        </p:txBody>
+      </p:sp>
+      <p:sp>
+        <p:nvSpPr>
+          <p:cNvPr id="5" name="Rectangle 4"/>
+          <p:cNvSpPr/>
+          <p:nvPr/>
+        </p:nvSpPr>
+        <p:spPr>
+          <a:xfrm>
+            <a:off x="0" y="5303520"/>
+            <a:ext cx="9144000" cy="365760"/>
+          </a:xfrm>
+          <a:prstGeom prst="rect">
+            <a:avLst/>
+          </a:prstGeom>
+          <a:solidFill>
+            <a:srgbClr val="0072FF"/>
+          </a:solidFill>
+          <a:ln>
+            <a:noFill/>
+          </a:ln>
+        </p:spPr>
+        <p:style>
+          <a:lnRef idx="1">
+            <a:schemeClr val="accent1"/>
+          </a:lnRef>
+          <a:fillRef idx="3">
+            <a:schemeClr val="accent1"/>
+          </a:fillRef>
+          <a:effectRef idx="2">
+            <a:schemeClr val="accent1"/>
+          </a:effectRef>
+          <a:fontRef idx="minor">
+            <a:schemeClr val="lt1"/>
+          </a:fontRef>
+        </p:style>
+        <p:txBody>
+          <a:bodyPr rtlCol="0" anchor="ctr"/>
+          <a:lstStyle/>
+          <a:p>
+            <a:pPr algn="ctr"/>
+            <a:endParaRPr/>
           </a:p>
         </p:txBody>
       </p:sp>
@@ -3169,8 +3262,8 @@
 </p:sld>
 </file>
 
-<file path=ppt/slides/slide10.xml><?xml version="1.0" encoding="utf-8"?>
-<p:sld xmlns:a="http://schemas.openxmlformats.org/drawingml/2006/main" xmlns:p="http://schemas.openxmlformats.org/presentationml/2006/main" xmlns:r="http://schemas.openxmlformats.org/officeDocument/2006/relationships">
+<file path=ppt/slides/slide2.xml><?xml version="1.0" encoding="utf-8"?>
+<p:sld xmlns:a="http://schemas.openxmlformats.org/drawingml/2006/main" xmlns:r="http://schemas.openxmlformats.org/officeDocument/2006/relationships" xmlns:p="http://schemas.openxmlformats.org/presentationml/2006/main">
   <p:cSld>
     <p:spTree>
       <p:nvGrpSpPr>
@@ -3178,24 +3271,528 @@
         <p:cNvGrpSpPr/>
         <p:nvPr/>
       </p:nvGrpSpPr>
-      <p:grpSpPr/>
-      <p:sp>
-        <p:nvSpPr>
-          <p:cNvPr id="2" name="Title 1"/>
-          <p:cNvSpPr>
-            <a:spLocks noGrp="1"/>
-          </p:cNvSpPr>
-          <p:nvPr>
-            <p:ph type="title"/>
-          </p:nvPr>
-        </p:nvSpPr>
-        <p:spPr/>
-        <p:txBody>
-          <a:bodyPr/>
-          <a:lstStyle/>
-          <a:p>
-            <a:r>
-              <a:t>03 Candidate Ranking Chart</a:t>
+      <p:grpSpPr>
+        <a:xfrm>
+          <a:off x="0" y="0"/>
+          <a:ext cx="0" cy="0"/>
+          <a:chOff x="0" y="0"/>
+          <a:chExt cx="0" cy="0"/>
+        </a:xfrm>
+      </p:grpSpPr>
+      <p:sp>
+        <p:nvSpPr>
+          <p:cNvPr id="2" name="TextBox 1"/>
+          <p:cNvSpPr txBox="1"/>
+          <p:nvPr/>
+        </p:nvSpPr>
+        <p:spPr>
+          <a:xfrm>
+            <a:off x="457200" y="274320"/>
+            <a:ext cx="8229600" cy="914400"/>
+          </a:xfrm>
+          <a:prstGeom prst="rect">
+            <a:avLst/>
+          </a:prstGeom>
+          <a:noFill/>
+        </p:spPr>
+        <p:txBody>
+          <a:bodyPr wrap="none">
+            <a:spAutoFit/>
+          </a:bodyPr>
+          <a:lstStyle/>
+          <a:p>
+            <a:pPr>
+              <a:defRPr sz="4000" b="1">
+                <a:solidFill>
+                  <a:srgbClr val="14235A"/>
+                </a:solidFill>
+              </a:defRPr>
+            </a:pPr>
+            <a:r>
+              <a:t>Project Summary</a:t>
+            </a:r>
+          </a:p>
+        </p:txBody>
+      </p:sp>
+      <p:sp>
+        <p:nvSpPr>
+          <p:cNvPr id="3" name="TextBox 2"/>
+          <p:cNvSpPr txBox="1"/>
+          <p:nvPr/>
+        </p:nvSpPr>
+        <p:spPr>
+          <a:xfrm>
+            <a:off x="457200" y="1280160"/>
+            <a:ext cx="7960962" cy="1538883"/>
+          </a:xfrm>
+          <a:prstGeom prst="rect">
+            <a:avLst/>
+          </a:prstGeom>
+          <a:noFill/>
+        </p:spPr>
+        <p:txBody>
+          <a:bodyPr wrap="none">
+            <a:spAutoFit/>
+          </a:bodyPr>
+          <a:lstStyle/>
+          <a:p>
+            <a:pPr>
+              <a:defRPr sz="2000">
+                <a:solidFill>
+                  <a:srgbClr val="233264"/>
+                </a:solidFill>
+              </a:defRPr>
+            </a:pPr>
+            <a:r>
+              <a:rPr dirty="0"/>
+              <a:t>A modern HR Tech solution that automates resume screening by matching </a:t>
+            </a:r>
+            <a:endParaRPr lang="en-US" dirty="0"/>
+          </a:p>
+          <a:p>
+            <a:pPr>
+              <a:defRPr sz="2000">
+                <a:solidFill>
+                  <a:srgbClr val="233264"/>
+                </a:solidFill>
+              </a:defRPr>
+            </a:pPr>
+            <a:r>
+              <a:rPr dirty="0"/>
+              <a:t>candidate resumes to job descriptions.</a:t>
+            </a:r>
+          </a:p>
+          <a:p>
+            <a:pPr lvl="1">
+              <a:defRPr sz="1800">
+                <a:solidFill>
+                  <a:srgbClr val="1056A4"/>
+                </a:solidFill>
+              </a:defRPr>
+            </a:pPr>
+            <a:r>
+              <a:rPr dirty="0"/>
+              <a:t>Rank candidates by final match score</a:t>
+            </a:r>
+          </a:p>
+          <a:p>
+            <a:pPr lvl="1">
+              <a:defRPr sz="1800">
+                <a:solidFill>
+                  <a:srgbClr val="1056A4"/>
+                </a:solidFill>
+              </a:defRPr>
+            </a:pPr>
+            <a:r>
+              <a:rPr dirty="0"/>
+              <a:t>Analyze skill gaps vs job requirements</a:t>
+            </a:r>
+          </a:p>
+          <a:p>
+            <a:pPr lvl="1">
+              <a:defRPr sz="1800">
+                <a:solidFill>
+                  <a:srgbClr val="1056A4"/>
+                </a:solidFill>
+              </a:defRPr>
+            </a:pPr>
+            <a:r>
+              <a:rPr dirty="0"/>
+              <a:t>Provide explainable recruiter recommendations</a:t>
+            </a:r>
+          </a:p>
+        </p:txBody>
+      </p:sp>
+      <p:sp>
+        <p:nvSpPr>
+          <p:cNvPr id="4" name="Rounded Rectangle 3"/>
+          <p:cNvSpPr/>
+          <p:nvPr/>
+        </p:nvSpPr>
+        <p:spPr>
+          <a:xfrm>
+            <a:off x="5236590" y="2880360"/>
+            <a:ext cx="3657600" cy="3200400"/>
+          </a:xfrm>
+          <a:prstGeom prst="roundRect">
+            <a:avLst/>
+          </a:prstGeom>
+          <a:solidFill>
+            <a:srgbClr val="EFF8FF"/>
+          </a:solidFill>
+          <a:ln>
+            <a:solidFill>
+              <a:srgbClr val="0072FF"/>
+            </a:solidFill>
+          </a:ln>
+        </p:spPr>
+        <p:style>
+          <a:lnRef idx="1">
+            <a:schemeClr val="accent1"/>
+          </a:lnRef>
+          <a:fillRef idx="3">
+            <a:schemeClr val="accent1"/>
+          </a:fillRef>
+          <a:effectRef idx="2">
+            <a:schemeClr val="accent1"/>
+          </a:effectRef>
+          <a:fontRef idx="minor">
+            <a:schemeClr val="lt1"/>
+          </a:fontRef>
+        </p:style>
+        <p:txBody>
+          <a:bodyPr rtlCol="0" anchor="ctr"/>
+          <a:lstStyle/>
+          <a:p>
+            <a:pPr>
+              <a:defRPr sz="2400" b="1">
+                <a:solidFill>
+                  <a:srgbClr val="0C3C70"/>
+                </a:solidFill>
+              </a:defRPr>
+            </a:pPr>
+            <a:r>
+              <a:t>Key Features</a:t>
+            </a:r>
+          </a:p>
+          <a:p>
+            <a:pPr lvl="1">
+              <a:defRPr sz="1600">
+                <a:solidFill>
+                  <a:srgbClr val="175FA6"/>
+                </a:solidFill>
+              </a:defRPr>
+            </a:pPr>
+            <a:r>
+              <a:t>Skill Extraction</a:t>
+            </a:r>
+          </a:p>
+          <a:p>
+            <a:pPr lvl="1">
+              <a:defRPr sz="1600">
+                <a:solidFill>
+                  <a:srgbClr val="175FA6"/>
+                </a:solidFill>
+              </a:defRPr>
+            </a:pPr>
+            <a:r>
+              <a:t>Semantic Matching</a:t>
+            </a:r>
+          </a:p>
+          <a:p>
+            <a:pPr lvl="1">
+              <a:defRPr sz="1600">
+                <a:solidFill>
+                  <a:srgbClr val="175FA6"/>
+                </a:solidFill>
+              </a:defRPr>
+            </a:pPr>
+            <a:r>
+              <a:t>Candidate Ranking</a:t>
+            </a:r>
+          </a:p>
+          <a:p>
+            <a:pPr lvl="1">
+              <a:defRPr sz="1600">
+                <a:solidFill>
+                  <a:srgbClr val="175FA6"/>
+                </a:solidFill>
+              </a:defRPr>
+            </a:pPr>
+            <a:r>
+              <a:t>Dashboard Deployment</a:t>
+            </a:r>
+          </a:p>
+        </p:txBody>
+      </p:sp>
+    </p:spTree>
+  </p:cSld>
+  <p:clrMapOvr>
+    <a:masterClrMapping/>
+  </p:clrMapOvr>
+</p:sld>
+</file>
+
+<file path=ppt/slides/slide3.xml><?xml version="1.0" encoding="utf-8"?>
+<p:sld xmlns:a="http://schemas.openxmlformats.org/drawingml/2006/main" xmlns:r="http://schemas.openxmlformats.org/officeDocument/2006/relationships" xmlns:p="http://schemas.openxmlformats.org/presentationml/2006/main">
+  <p:cSld>
+    <p:spTree>
+      <p:nvGrpSpPr>
+        <p:cNvPr id="1" name=""/>
+        <p:cNvGrpSpPr/>
+        <p:nvPr/>
+      </p:nvGrpSpPr>
+      <p:grpSpPr>
+        <a:xfrm>
+          <a:off x="0" y="0"/>
+          <a:ext cx="0" cy="0"/>
+          <a:chOff x="0" y="0"/>
+          <a:chExt cx="0" cy="0"/>
+        </a:xfrm>
+      </p:grpSpPr>
+      <p:sp>
+        <p:nvSpPr>
+          <p:cNvPr id="2" name="TextBox 1"/>
+          <p:cNvSpPr txBox="1"/>
+          <p:nvPr/>
+        </p:nvSpPr>
+        <p:spPr>
+          <a:xfrm>
+            <a:off x="457200" y="274320"/>
+            <a:ext cx="8229600" cy="731520"/>
+          </a:xfrm>
+          <a:prstGeom prst="rect">
+            <a:avLst/>
+          </a:prstGeom>
+          <a:noFill/>
+        </p:spPr>
+        <p:txBody>
+          <a:bodyPr wrap="none">
+            <a:spAutoFit/>
+          </a:bodyPr>
+          <a:lstStyle/>
+          <a:p>
+            <a:pPr>
+              <a:defRPr sz="4000" b="1"/>
+            </a:pPr>
+            <a:r>
+              <a:t>Data &amp; Model Approach</a:t>
+            </a:r>
+          </a:p>
+        </p:txBody>
+      </p:sp>
+      <p:sp>
+        <p:nvSpPr>
+          <p:cNvPr id="3" name="Rounded Rectangle 2"/>
+          <p:cNvSpPr/>
+          <p:nvPr/>
+        </p:nvSpPr>
+        <p:spPr>
+          <a:xfrm>
+            <a:off x="457200" y="1188720"/>
+            <a:ext cx="3931920" cy="3749039"/>
+          </a:xfrm>
+          <a:prstGeom prst="roundRect">
+            <a:avLst/>
+          </a:prstGeom>
+          <a:solidFill>
+            <a:srgbClr val="FCFAFF"/>
+          </a:solidFill>
+          <a:ln>
+            <a:solidFill>
+              <a:srgbClr val="874BC8"/>
+            </a:solidFill>
+          </a:ln>
+        </p:spPr>
+        <p:style>
+          <a:lnRef idx="1">
+            <a:schemeClr val="accent1"/>
+          </a:lnRef>
+          <a:fillRef idx="3">
+            <a:schemeClr val="accent1"/>
+          </a:fillRef>
+          <a:effectRef idx="2">
+            <a:schemeClr val="accent1"/>
+          </a:effectRef>
+          <a:fontRef idx="minor">
+            <a:schemeClr val="lt1"/>
+          </a:fontRef>
+        </p:style>
+        <p:txBody>
+          <a:bodyPr rtlCol="0" anchor="ctr"/>
+          <a:lstStyle/>
+          <a:p>
+            <a:pPr>
+              <a:defRPr sz="2400" b="1">
+                <a:solidFill>
+                  <a:srgbClr val="58289C"/>
+                </a:solidFill>
+              </a:defRPr>
+            </a:pPr>
+            <a:r>
+              <a:t>Data</a:t>
+            </a:r>
+          </a:p>
+          <a:p>
+            <a:pPr lvl="1">
+              <a:defRPr sz="1600">
+                <a:solidFill>
+                  <a:srgbClr val="2D2F58"/>
+                </a:solidFill>
+              </a:defRPr>
+            </a:pPr>
+            <a:r>
+              <a:t>• Hugging Face resume-job matching dataset</a:t>
+            </a:r>
+          </a:p>
+          <a:p>
+            <a:pPr lvl="1">
+              <a:defRPr sz="1600">
+                <a:solidFill>
+                  <a:srgbClr val="2D2F58"/>
+                </a:solidFill>
+              </a:defRPr>
+            </a:pPr>
+            <a:r>
+              <a:t>• Cleaned job descriptions + PDF resumes</a:t>
+            </a:r>
+          </a:p>
+          <a:p>
+            <a:pPr lvl="1">
+              <a:defRPr sz="1600">
+                <a:solidFill>
+                  <a:srgbClr val="2D2F58"/>
+                </a:solidFill>
+              </a:defRPr>
+            </a:pPr>
+            <a:r>
+              <a:t>• Skill extraction and resume parsing</a:t>
+            </a:r>
+          </a:p>
+        </p:txBody>
+      </p:sp>
+      <p:sp>
+        <p:nvSpPr>
+          <p:cNvPr id="4" name="Rounded Rectangle 3"/>
+          <p:cNvSpPr/>
+          <p:nvPr/>
+        </p:nvSpPr>
+        <p:spPr>
+          <a:xfrm>
+            <a:off x="4754880" y="1188720"/>
+            <a:ext cx="3931920" cy="3749039"/>
+          </a:xfrm>
+          <a:prstGeom prst="roundRect">
+            <a:avLst/>
+          </a:prstGeom>
+          <a:solidFill>
+            <a:srgbClr val="EFF8FF"/>
+          </a:solidFill>
+          <a:ln>
+            <a:solidFill>
+              <a:srgbClr val="1874CA"/>
+            </a:solidFill>
+          </a:ln>
+        </p:spPr>
+        <p:style>
+          <a:lnRef idx="1">
+            <a:schemeClr val="accent1"/>
+          </a:lnRef>
+          <a:fillRef idx="3">
+            <a:schemeClr val="accent1"/>
+          </a:fillRef>
+          <a:effectRef idx="2">
+            <a:schemeClr val="accent1"/>
+          </a:effectRef>
+          <a:fontRef idx="minor">
+            <a:schemeClr val="lt1"/>
+          </a:fontRef>
+        </p:style>
+        <p:txBody>
+          <a:bodyPr rtlCol="0" anchor="ctr"/>
+          <a:lstStyle/>
+          <a:p>
+            <a:pPr>
+              <a:defRPr sz="2400" b="1">
+                <a:solidFill>
+                  <a:srgbClr val="0E5091"/>
+                </a:solidFill>
+              </a:defRPr>
+            </a:pPr>
+            <a:r>
+              <a:t>Approach</a:t>
+            </a:r>
+          </a:p>
+          <a:p>
+            <a:pPr lvl="1">
+              <a:defRPr sz="1600">
+                <a:solidFill>
+                  <a:srgbClr val="1B406A"/>
+                </a:solidFill>
+              </a:defRPr>
+            </a:pPr>
+            <a:r>
+              <a:t>• SBERT embeddings for semantic similarity</a:t>
+            </a:r>
+          </a:p>
+          <a:p>
+            <a:pPr lvl="1">
+              <a:defRPr sz="1600">
+                <a:solidFill>
+                  <a:srgbClr val="1B406A"/>
+                </a:solidFill>
+              </a:defRPr>
+            </a:pPr>
+            <a:r>
+              <a:t>• XGBoost classifier with feature fusion</a:t>
+            </a:r>
+          </a:p>
+          <a:p>
+            <a:pPr lvl="1">
+              <a:defRPr sz="1600">
+                <a:solidFill>
+                  <a:srgbClr val="1B406A"/>
+                </a:solidFill>
+              </a:defRPr>
+            </a:pPr>
+            <a:r>
+              <a:t>• Combined skill + semantic scoring</a:t>
+            </a:r>
+          </a:p>
+        </p:txBody>
+      </p:sp>
+    </p:spTree>
+  </p:cSld>
+  <p:clrMapOvr>
+    <a:masterClrMapping/>
+  </p:clrMapOvr>
+</p:sld>
+</file>
+
+<file path=ppt/slides/slide4.xml><?xml version="1.0" encoding="utf-8"?>
+<p:sld xmlns:a="http://schemas.openxmlformats.org/drawingml/2006/main" xmlns:r="http://schemas.openxmlformats.org/officeDocument/2006/relationships" xmlns:p="http://schemas.openxmlformats.org/presentationml/2006/main">
+  <p:cSld>
+    <p:spTree>
+      <p:nvGrpSpPr>
+        <p:cNvPr id="1" name=""/>
+        <p:cNvGrpSpPr/>
+        <p:nvPr/>
+      </p:nvGrpSpPr>
+      <p:grpSpPr>
+        <a:xfrm>
+          <a:off x="0" y="0"/>
+          <a:ext cx="0" cy="0"/>
+          <a:chOff x="0" y="0"/>
+          <a:chExt cx="0" cy="0"/>
+        </a:xfrm>
+      </p:grpSpPr>
+      <p:sp>
+        <p:nvSpPr>
+          <p:cNvPr id="2" name="TextBox 1"/>
+          <p:cNvSpPr txBox="1"/>
+          <p:nvPr/>
+        </p:nvSpPr>
+        <p:spPr>
+          <a:xfrm>
+            <a:off x="457200" y="274320"/>
+            <a:ext cx="8229600" cy="731520"/>
+          </a:xfrm>
+          <a:prstGeom prst="rect">
+            <a:avLst/>
+          </a:prstGeom>
+          <a:noFill/>
+        </p:spPr>
+        <p:txBody>
+          <a:bodyPr wrap="none">
+            <a:spAutoFit/>
+          </a:bodyPr>
+          <a:lstStyle/>
+          <a:p>
+            <a:pPr>
+              <a:defRPr sz="4000" b="1"/>
+            </a:pPr>
+            <a:r>
+              <a:t>Candidate Ranking</a:t>
             </a:r>
           </a:p>
         </p:txBody>
@@ -3216,14 +3813,89 @@
         </p:blipFill>
         <p:spPr>
           <a:xfrm>
-            <a:off x="457200" y="1371600"/>
-            <a:ext cx="14991127" cy="4572000"/>
+            <a:off x="594419" y="1005840"/>
+            <a:ext cx="8549581" cy="3094820"/>
           </a:xfrm>
           <a:prstGeom prst="rect">
             <a:avLst/>
           </a:prstGeom>
         </p:spPr>
       </p:pic>
+      <p:sp>
+        <p:nvSpPr>
+          <p:cNvPr id="4" name="TextBox 3"/>
+          <p:cNvSpPr txBox="1"/>
+          <p:nvPr/>
+        </p:nvSpPr>
+        <p:spPr>
+          <a:xfrm>
+            <a:off x="4487159" y="4186444"/>
+            <a:ext cx="3474720" cy="1815882"/>
+          </a:xfrm>
+          <a:prstGeom prst="rect">
+            <a:avLst/>
+          </a:prstGeom>
+          <a:noFill/>
+        </p:spPr>
+        <p:txBody>
+          <a:bodyPr wrap="square">
+            <a:spAutoFit/>
+          </a:bodyPr>
+          <a:lstStyle/>
+          <a:p>
+            <a:pPr>
+              <a:defRPr sz="2000">
+                <a:solidFill>
+                  <a:srgbClr val="12285B"/>
+                </a:solidFill>
+              </a:defRPr>
+            </a:pPr>
+            <a:r>
+              <a:rPr dirty="0"/>
+              <a:t>The system ranks candidates by: </a:t>
+            </a:r>
+          </a:p>
+          <a:p>
+            <a:pPr lvl="1">
+              <a:defRPr sz="1800">
+                <a:solidFill>
+                  <a:srgbClr val="1B4D98"/>
+                </a:solidFill>
+              </a:defRPr>
+            </a:pPr>
+            <a:r>
+              <a:rPr dirty="0"/>
+              <a:t>60% skill score</a:t>
+            </a:r>
+          </a:p>
+          <a:p>
+            <a:pPr lvl="1">
+              <a:defRPr sz="1800">
+                <a:solidFill>
+                  <a:srgbClr val="1B4D98"/>
+                </a:solidFill>
+              </a:defRPr>
+            </a:pPr>
+            <a:r>
+              <a:rPr dirty="0"/>
+              <a:t>40% semantic score</a:t>
+            </a:r>
+          </a:p>
+          <a:p>
+            <a:pPr lvl="1">
+              <a:defRPr sz="1800">
+                <a:solidFill>
+                  <a:srgbClr val="1B4D98"/>
+                </a:solidFill>
+              </a:defRPr>
+            </a:pPr>
+            <a:r>
+              <a:rPr dirty="0"/>
+              <a:t>Clear fit categories and recommendations</a:t>
+            </a:r>
+          </a:p>
+        </p:txBody>
+      </p:sp>
     </p:spTree>
   </p:cSld>
   <p:clrMapOvr>
@@ -3232,8 +3904,8 @@
 </p:sld>
 </file>
 
-<file path=ppt/slides/slide11.xml><?xml version="1.0" encoding="utf-8"?>
-<p:sld xmlns:a="http://schemas.openxmlformats.org/drawingml/2006/main" xmlns:p="http://schemas.openxmlformats.org/presentationml/2006/main" xmlns:r="http://schemas.openxmlformats.org/officeDocument/2006/relationships">
+<file path=ppt/slides/slide5.xml><?xml version="1.0" encoding="utf-8"?>
+<p:sld xmlns:a="http://schemas.openxmlformats.org/drawingml/2006/main" xmlns:r="http://schemas.openxmlformats.org/officeDocument/2006/relationships" xmlns:p="http://schemas.openxmlformats.org/presentationml/2006/main">
   <p:cSld>
     <p:spTree>
       <p:nvGrpSpPr>
@@ -3241,24 +3913,41 @@
         <p:cNvGrpSpPr/>
         <p:nvPr/>
       </p:nvGrpSpPr>
-      <p:grpSpPr/>
-      <p:sp>
-        <p:nvSpPr>
-          <p:cNvPr id="2" name="Title 1"/>
-          <p:cNvSpPr>
-            <a:spLocks noGrp="1"/>
-          </p:cNvSpPr>
-          <p:nvPr>
-            <p:ph type="title"/>
-          </p:nvPr>
-        </p:nvSpPr>
-        <p:spPr/>
-        <p:txBody>
-          <a:bodyPr/>
-          <a:lstStyle/>
-          <a:p>
-            <a:r>
-              <a:t>04 Top Candidate Summary</a:t>
+      <p:grpSpPr>
+        <a:xfrm>
+          <a:off x="0" y="0"/>
+          <a:ext cx="0" cy="0"/>
+          <a:chOff x="0" y="0"/>
+          <a:chExt cx="0" cy="0"/>
+        </a:xfrm>
+      </p:grpSpPr>
+      <p:sp>
+        <p:nvSpPr>
+          <p:cNvPr id="2" name="TextBox 1"/>
+          <p:cNvSpPr txBox="1"/>
+          <p:nvPr/>
+        </p:nvSpPr>
+        <p:spPr>
+          <a:xfrm>
+            <a:off x="457200" y="274320"/>
+            <a:ext cx="8229600" cy="731520"/>
+          </a:xfrm>
+          <a:prstGeom prst="rect">
+            <a:avLst/>
+          </a:prstGeom>
+          <a:noFill/>
+        </p:spPr>
+        <p:txBody>
+          <a:bodyPr wrap="none">
+            <a:spAutoFit/>
+          </a:bodyPr>
+          <a:lstStyle/>
+          <a:p>
+            <a:pPr>
+              <a:defRPr sz="4000" b="1"/>
+            </a:pPr>
+            <a:r>
+              <a:t>Top Candidate Insights</a:t>
             </a:r>
           </a:p>
         </p:txBody>
@@ -3279,14 +3968,89 @@
         </p:blipFill>
         <p:spPr>
           <a:xfrm>
-            <a:off x="457200" y="1371600"/>
-            <a:ext cx="10356139" cy="4572000"/>
+            <a:off x="457199" y="1097279"/>
+            <a:ext cx="8686801" cy="3331457"/>
           </a:xfrm>
           <a:prstGeom prst="rect">
             <a:avLst/>
           </a:prstGeom>
         </p:spPr>
       </p:pic>
+      <p:sp>
+        <p:nvSpPr>
+          <p:cNvPr id="4" name="TextBox 3"/>
+          <p:cNvSpPr txBox="1"/>
+          <p:nvPr/>
+        </p:nvSpPr>
+        <p:spPr>
+          <a:xfrm>
+            <a:off x="4981124" y="4707516"/>
+            <a:ext cx="3474720" cy="1908215"/>
+          </a:xfrm>
+          <a:prstGeom prst="rect">
+            <a:avLst/>
+          </a:prstGeom>
+          <a:noFill/>
+        </p:spPr>
+        <p:txBody>
+          <a:bodyPr wrap="square">
+            <a:spAutoFit/>
+          </a:bodyPr>
+          <a:lstStyle/>
+          <a:p>
+            <a:pPr>
+              <a:defRPr sz="1800">
+                <a:solidFill>
+                  <a:srgbClr val="193C74"/>
+                </a:solidFill>
+              </a:defRPr>
+            </a:pPr>
+            <a:r>
+              <a:rPr dirty="0"/>
+              <a:t>This slide explains why the top candidate stands out and highlights matched/missing skills.</a:t>
+            </a:r>
+          </a:p>
+          <a:p>
+            <a:pPr lvl="1">
+              <a:defRPr sz="1600">
+                <a:solidFill>
+                  <a:srgbClr val="18569C"/>
+                </a:solidFill>
+              </a:defRPr>
+            </a:pPr>
+            <a:r>
+              <a:rPr dirty="0"/>
+              <a:t>• Best overall match score</a:t>
+            </a:r>
+          </a:p>
+          <a:p>
+            <a:pPr lvl="1">
+              <a:defRPr sz="1600">
+                <a:solidFill>
+                  <a:srgbClr val="18569C"/>
+                </a:solidFill>
+              </a:defRPr>
+            </a:pPr>
+            <a:r>
+              <a:rPr dirty="0"/>
+              <a:t>• Strong recruiter recommendation</a:t>
+            </a:r>
+          </a:p>
+          <a:p>
+            <a:pPr lvl="1">
+              <a:defRPr sz="1600">
+                <a:solidFill>
+                  <a:srgbClr val="18569C"/>
+                </a:solidFill>
+              </a:defRPr>
+            </a:pPr>
+            <a:r>
+              <a:rPr dirty="0"/>
+              <a:t>• Transparent skill gap reasoning</a:t>
+            </a:r>
+          </a:p>
+        </p:txBody>
+      </p:sp>
     </p:spTree>
   </p:cSld>
   <p:clrMapOvr>
@@ -3295,8 +4059,8 @@
 </p:sld>
 </file>
 
-<file path=ppt/slides/slide12.xml><?xml version="1.0" encoding="utf-8"?>
-<p:sld xmlns:a="http://schemas.openxmlformats.org/drawingml/2006/main" xmlns:p="http://schemas.openxmlformats.org/presentationml/2006/main" xmlns:r="http://schemas.openxmlformats.org/officeDocument/2006/relationships">
+<file path=ppt/slides/slide6.xml><?xml version="1.0" encoding="utf-8"?>
+<p:sld xmlns:a="http://schemas.openxmlformats.org/drawingml/2006/main" xmlns:r="http://schemas.openxmlformats.org/officeDocument/2006/relationships" xmlns:p="http://schemas.openxmlformats.org/presentationml/2006/main">
   <p:cSld>
     <p:spTree>
       <p:nvGrpSpPr>
@@ -3304,24 +4068,41 @@
         <p:cNvGrpSpPr/>
         <p:nvPr/>
       </p:nvGrpSpPr>
-      <p:grpSpPr/>
-      <p:sp>
-        <p:nvSpPr>
-          <p:cNvPr id="2" name="Title 1"/>
-          <p:cNvSpPr>
-            <a:spLocks noGrp="1"/>
-          </p:cNvSpPr>
-          <p:nvPr>
-            <p:ph type="title"/>
-          </p:nvPr>
-        </p:nvSpPr>
-        <p:spPr/>
-        <p:txBody>
-          <a:bodyPr/>
-          <a:lstStyle/>
-          <a:p>
-            <a:r>
-              <a:t>05 Skill Gap Analysis</a:t>
+      <p:grpSpPr>
+        <a:xfrm>
+          <a:off x="0" y="0"/>
+          <a:ext cx="0" cy="0"/>
+          <a:chOff x="0" y="0"/>
+          <a:chExt cx="0" cy="0"/>
+        </a:xfrm>
+      </p:grpSpPr>
+      <p:sp>
+        <p:nvSpPr>
+          <p:cNvPr id="2" name="TextBox 1"/>
+          <p:cNvSpPr txBox="1"/>
+          <p:nvPr/>
+        </p:nvSpPr>
+        <p:spPr>
+          <a:xfrm>
+            <a:off x="457200" y="274320"/>
+            <a:ext cx="8229600" cy="731520"/>
+          </a:xfrm>
+          <a:prstGeom prst="rect">
+            <a:avLst/>
+          </a:prstGeom>
+          <a:noFill/>
+        </p:spPr>
+        <p:txBody>
+          <a:bodyPr wrap="none">
+            <a:spAutoFit/>
+          </a:bodyPr>
+          <a:lstStyle/>
+          <a:p>
+            <a:pPr>
+              <a:defRPr sz="4000" b="1"/>
+            </a:pPr>
+            <a:r>
+              <a:t>Skill Gap Analysis</a:t>
             </a:r>
           </a:p>
         </p:txBody>
@@ -3342,418 +4123,85 @@
         </p:blipFill>
         <p:spPr>
           <a:xfrm>
-            <a:off x="457200" y="1371600"/>
-            <a:ext cx="12488853" cy="4572000"/>
+            <a:off x="457200" y="1097280"/>
+            <a:ext cx="7536730" cy="2759095"/>
           </a:xfrm>
           <a:prstGeom prst="rect">
             <a:avLst/>
           </a:prstGeom>
         </p:spPr>
       </p:pic>
-    </p:spTree>
-  </p:cSld>
-  <p:clrMapOvr>
-    <a:masterClrMapping/>
-  </p:clrMapOvr>
-</p:sld>
-</file>
-
-<file path=ppt/slides/slide2.xml><?xml version="1.0" encoding="utf-8"?>
-<p:sld xmlns:a="http://schemas.openxmlformats.org/drawingml/2006/main" xmlns:p="http://schemas.openxmlformats.org/presentationml/2006/main" xmlns:r="http://schemas.openxmlformats.org/officeDocument/2006/relationships">
-  <p:cSld>
-    <p:spTree>
-      <p:nvGrpSpPr>
-        <p:cNvPr id="1" name=""/>
-        <p:cNvGrpSpPr/>
-        <p:nvPr/>
-      </p:nvGrpSpPr>
-      <p:grpSpPr/>
-      <p:sp>
-        <p:nvSpPr>
-          <p:cNvPr id="2" name="Title 1"/>
-          <p:cNvSpPr>
-            <a:spLocks noGrp="1"/>
-          </p:cNvSpPr>
-          <p:nvPr>
-            <p:ph type="title"/>
-          </p:nvPr>
-        </p:nvSpPr>
-        <p:spPr/>
-        <p:txBody>
-          <a:bodyPr/>
-          <a:lstStyle/>
-          <a:p>
-            <a:r>
-              <a:t>Project Objective</a:t>
-            </a:r>
-          </a:p>
-        </p:txBody>
-      </p:sp>
-      <p:sp>
-        <p:nvSpPr>
-          <p:cNvPr id="3" name="Content Placeholder 2"/>
-          <p:cNvSpPr>
-            <a:spLocks noGrp="1"/>
-          </p:cNvSpPr>
-          <p:nvPr>
-            <p:ph idx="1"/>
-          </p:nvPr>
-        </p:nvSpPr>
-        <p:spPr/>
-        <p:txBody>
-          <a:bodyPr/>
-          <a:lstStyle/>
-          <a:p/>
+      <p:sp>
+        <p:nvSpPr>
+          <p:cNvPr id="4" name="TextBox 3"/>
+          <p:cNvSpPr txBox="1"/>
+          <p:nvPr/>
+        </p:nvSpPr>
+        <p:spPr>
+          <a:xfrm>
+            <a:off x="4349527" y="3916290"/>
+            <a:ext cx="3474720" cy="2400657"/>
+          </a:xfrm>
+          <a:prstGeom prst="rect">
+            <a:avLst/>
+          </a:prstGeom>
+          <a:noFill/>
+        </p:spPr>
+        <p:txBody>
+          <a:bodyPr wrap="square">
+            <a:spAutoFit/>
+          </a:bodyPr>
+          <a:lstStyle/>
           <a:p>
             <a:pPr>
-              <a:defRPr sz="1800"/>
+              <a:defRPr sz="1800">
+                <a:solidFill>
+                  <a:srgbClr val="16335F"/>
+                </a:solidFill>
+              </a:defRPr>
             </a:pPr>
             <a:r>
-              <a:t>Rank candidates against a job description.</a:t>
-            </a:r>
-          </a:p>
-          <a:p>
-            <a:pPr>
-              <a:defRPr sz="1800"/>
+              <a:rPr dirty="0"/>
+              <a:t>The skill gap visual explains missing and matched skills for better hiring decisions.</a:t>
+            </a:r>
+          </a:p>
+          <a:p>
+            <a:pPr lvl="1">
+              <a:defRPr sz="1600">
+                <a:solidFill>
+                  <a:srgbClr val="1656A3"/>
+                </a:solidFill>
+              </a:defRPr>
             </a:pPr>
             <a:r>
-              <a:t>Predict fit categories and explain skill gaps.</a:t>
-            </a:r>
-          </a:p>
-          <a:p>
-            <a:pPr>
-              <a:defRPr sz="1800"/>
+              <a:rPr dirty="0"/>
+              <a:t>• Compare JD skills vs resume skills</a:t>
+            </a:r>
+          </a:p>
+          <a:p>
+            <a:pPr lvl="1">
+              <a:defRPr sz="1600">
+                <a:solidFill>
+                  <a:srgbClr val="1656A3"/>
+                </a:solidFill>
+              </a:defRPr>
             </a:pPr>
             <a:r>
-              <a:t>Provide recruiter-friendly recommendations.</a:t>
-            </a:r>
-          </a:p>
-        </p:txBody>
-      </p:sp>
-    </p:spTree>
-  </p:cSld>
-  <p:clrMapOvr>
-    <a:masterClrMapping/>
-  </p:clrMapOvr>
-</p:sld>
-</file>
-
-<file path=ppt/slides/slide3.xml><?xml version="1.0" encoding="utf-8"?>
-<p:sld xmlns:a="http://schemas.openxmlformats.org/drawingml/2006/main" xmlns:p="http://schemas.openxmlformats.org/presentationml/2006/main" xmlns:r="http://schemas.openxmlformats.org/officeDocument/2006/relationships">
-  <p:cSld>
-    <p:spTree>
-      <p:nvGrpSpPr>
-        <p:cNvPr id="1" name=""/>
-        <p:cNvGrpSpPr/>
-        <p:nvPr/>
-      </p:nvGrpSpPr>
-      <p:grpSpPr/>
-      <p:sp>
-        <p:nvSpPr>
-          <p:cNvPr id="2" name="Title 1"/>
-          <p:cNvSpPr>
-            <a:spLocks noGrp="1"/>
-          </p:cNvSpPr>
-          <p:nvPr>
-            <p:ph type="title"/>
-          </p:nvPr>
-        </p:nvSpPr>
-        <p:spPr/>
-        <p:txBody>
-          <a:bodyPr/>
-          <a:lstStyle/>
-          <a:p>
-            <a:r>
-              <a:t>Data &amp; Approach</a:t>
-            </a:r>
-          </a:p>
-        </p:txBody>
-      </p:sp>
-      <p:sp>
-        <p:nvSpPr>
-          <p:cNvPr id="3" name="Content Placeholder 2"/>
-          <p:cNvSpPr>
-            <a:spLocks noGrp="1"/>
-          </p:cNvSpPr>
-          <p:nvPr>
-            <p:ph idx="1"/>
-          </p:nvPr>
-        </p:nvSpPr>
-        <p:spPr/>
-        <p:txBody>
-          <a:bodyPr/>
-          <a:lstStyle/>
-          <a:p/>
-          <a:p>
-            <a:pPr>
-              <a:defRPr sz="1800"/>
+              <a:rPr dirty="0"/>
+              <a:t>• Identify development opportunities</a:t>
+            </a:r>
+          </a:p>
+          <a:p>
+            <a:pPr lvl="1">
+              <a:defRPr sz="1600">
+                <a:solidFill>
+                  <a:srgbClr val="1656A3"/>
+                </a:solidFill>
+              </a:defRPr>
             </a:pPr>
             <a:r>
-              <a:t>Dataset: Hugging Face facehuggerapoorv/resume-jd-match.</a:t>
-            </a:r>
-          </a:p>
-          <a:p>
-            <a:pPr>
-              <a:defRPr sz="1800"/>
-            </a:pPr>
-            <a:r>
-              <a:t>Steps: preprocessing, embeddings, baseline model, advanced model, deployment.</a:t>
-            </a:r>
-          </a:p>
-          <a:p>
-            <a:pPr>
-              <a:defRPr sz="1800"/>
-            </a:pPr>
-            <a:r>
-              <a:t>Baseline: TF-IDF + Logistic Regression; Advanced: SBERT + XGBoost.</a:t>
-            </a:r>
-          </a:p>
-        </p:txBody>
-      </p:sp>
-    </p:spTree>
-  </p:cSld>
-  <p:clrMapOvr>
-    <a:masterClrMapping/>
-  </p:clrMapOvr>
-</p:sld>
-</file>
-
-<file path=ppt/slides/slide4.xml><?xml version="1.0" encoding="utf-8"?>
-<p:sld xmlns:a="http://schemas.openxmlformats.org/drawingml/2006/main" xmlns:p="http://schemas.openxmlformats.org/presentationml/2006/main" xmlns:r="http://schemas.openxmlformats.org/officeDocument/2006/relationships">
-  <p:cSld>
-    <p:spTree>
-      <p:nvGrpSpPr>
-        <p:cNvPr id="1" name=""/>
-        <p:cNvGrpSpPr/>
-        <p:nvPr/>
-      </p:nvGrpSpPr>
-      <p:grpSpPr/>
-      <p:sp>
-        <p:nvSpPr>
-          <p:cNvPr id="2" name="Title 1"/>
-          <p:cNvSpPr>
-            <a:spLocks noGrp="1"/>
-          </p:cNvSpPr>
-          <p:nvPr>
-            <p:ph type="title"/>
-          </p:nvPr>
-        </p:nvSpPr>
-        <p:spPr/>
-        <p:txBody>
-          <a:bodyPr/>
-          <a:lstStyle/>
-          <a:p>
-            <a:r>
-              <a:t>Model Pipeline</a:t>
-            </a:r>
-          </a:p>
-        </p:txBody>
-      </p:sp>
-      <p:sp>
-        <p:nvSpPr>
-          <p:cNvPr id="3" name="Content Placeholder 2"/>
-          <p:cNvSpPr>
-            <a:spLocks noGrp="1"/>
-          </p:cNvSpPr>
-          <p:nvPr>
-            <p:ph idx="1"/>
-          </p:nvPr>
-        </p:nvSpPr>
-        <p:spPr/>
-        <p:txBody>
-          <a:bodyPr/>
-          <a:lstStyle/>
-          <a:p/>
-          <a:p>
-            <a:pPr>
-              <a:defRPr sz="1800"/>
-            </a:pPr>
-            <a:r>
-              <a:t>1. Clean JD and resume text.</a:t>
-            </a:r>
-          </a:p>
-          <a:p>
-            <a:pPr>
-              <a:defRPr sz="1800"/>
-            </a:pPr>
-            <a:r>
-              <a:t>2. Extract skills and compute skill gap.</a:t>
-            </a:r>
-          </a:p>
-          <a:p>
-            <a:pPr>
-              <a:defRPr sz="1800"/>
-            </a:pPr>
-            <a:r>
-              <a:t>3. Generate SBERT embeddings.</a:t>
-            </a:r>
-          </a:p>
-          <a:p>
-            <a:pPr>
-              <a:defRPr sz="1800"/>
-            </a:pPr>
-            <a:r>
-              <a:t>4. Train XGBoost classifier with feature augmentation.</a:t>
-            </a:r>
-          </a:p>
-        </p:txBody>
-      </p:sp>
-    </p:spTree>
-  </p:cSld>
-  <p:clrMapOvr>
-    <a:masterClrMapping/>
-  </p:clrMapOvr>
-</p:sld>
-</file>
-
-<file path=ppt/slides/slide5.xml><?xml version="1.0" encoding="utf-8"?>
-<p:sld xmlns:a="http://schemas.openxmlformats.org/drawingml/2006/main" xmlns:p="http://schemas.openxmlformats.org/presentationml/2006/main" xmlns:r="http://schemas.openxmlformats.org/officeDocument/2006/relationships">
-  <p:cSld>
-    <p:spTree>
-      <p:nvGrpSpPr>
-        <p:cNvPr id="1" name=""/>
-        <p:cNvGrpSpPr/>
-        <p:nvPr/>
-      </p:nvGrpSpPr>
-      <p:grpSpPr/>
-      <p:sp>
-        <p:nvSpPr>
-          <p:cNvPr id="2" name="Title 1"/>
-          <p:cNvSpPr>
-            <a:spLocks noGrp="1"/>
-          </p:cNvSpPr>
-          <p:nvPr>
-            <p:ph type="title"/>
-          </p:nvPr>
-        </p:nvSpPr>
-        <p:spPr/>
-        <p:txBody>
-          <a:bodyPr/>
-          <a:lstStyle/>
-          <a:p>
-            <a:r>
-              <a:t>Evaluation</a:t>
-            </a:r>
-          </a:p>
-        </p:txBody>
-      </p:sp>
-      <p:sp>
-        <p:nvSpPr>
-          <p:cNvPr id="3" name="Content Placeholder 2"/>
-          <p:cNvSpPr>
-            <a:spLocks noGrp="1"/>
-          </p:cNvSpPr>
-          <p:nvPr>
-            <p:ph idx="1"/>
-          </p:nvPr>
-        </p:nvSpPr>
-        <p:spPr/>
-        <p:txBody>
-          <a:bodyPr/>
-          <a:lstStyle/>
-          <a:p/>
-          <a:p>
-            <a:pPr>
-              <a:defRPr sz="1800"/>
-            </a:pPr>
-            <a:r>
-              <a:t>Primary metrics: Accuracy, F1, class-wise performance.</a:t>
-            </a:r>
-          </a:p>
-          <a:p>
-            <a:pPr>
-              <a:defRPr sz="1800"/>
-            </a:pPr>
-            <a:r>
-              <a:t>Validation and test evaluation with confusion matrix.</a:t>
-            </a:r>
-          </a:p>
-          <a:p>
-            <a:pPr>
-              <a:defRPr sz="1800"/>
-            </a:pPr>
-            <a:r>
-              <a:t>Limitations and responsible use documented.</a:t>
-            </a:r>
-          </a:p>
-        </p:txBody>
-      </p:sp>
-    </p:spTree>
-  </p:cSld>
-  <p:clrMapOvr>
-    <a:masterClrMapping/>
-  </p:clrMapOvr>
-</p:sld>
-</file>
-
-<file path=ppt/slides/slide6.xml><?xml version="1.0" encoding="utf-8"?>
-<p:sld xmlns:a="http://schemas.openxmlformats.org/drawingml/2006/main" xmlns:p="http://schemas.openxmlformats.org/presentationml/2006/main" xmlns:r="http://schemas.openxmlformats.org/officeDocument/2006/relationships">
-  <p:cSld>
-    <p:spTree>
-      <p:nvGrpSpPr>
-        <p:cNvPr id="1" name=""/>
-        <p:cNvGrpSpPr/>
-        <p:nvPr/>
-      </p:nvGrpSpPr>
-      <p:grpSpPr/>
-      <p:sp>
-        <p:nvSpPr>
-          <p:cNvPr id="2" name="Title 1"/>
-          <p:cNvSpPr>
-            <a:spLocks noGrp="1"/>
-          </p:cNvSpPr>
-          <p:nvPr>
-            <p:ph type="title"/>
-          </p:nvPr>
-        </p:nvSpPr>
-        <p:spPr/>
-        <p:txBody>
-          <a:bodyPr/>
-          <a:lstStyle/>
-          <a:p>
-            <a:r>
-              <a:t>Deployment</a:t>
-            </a:r>
-          </a:p>
-        </p:txBody>
-      </p:sp>
-      <p:sp>
-        <p:nvSpPr>
-          <p:cNvPr id="3" name="Content Placeholder 2"/>
-          <p:cNvSpPr>
-            <a:spLocks noGrp="1"/>
-          </p:cNvSpPr>
-          <p:nvPr>
-            <p:ph idx="1"/>
-          </p:nvPr>
-        </p:nvSpPr>
-        <p:spPr/>
-        <p:txBody>
-          <a:bodyPr/>
-          <a:lstStyle/>
-          <a:p/>
-          <a:p>
-            <a:pPr>
-              <a:defRPr sz="1800"/>
-            </a:pPr>
-            <a:r>
-              <a:t>Streamlit dashboard for JD resume matching.</a:t>
-            </a:r>
-          </a:p>
-          <a:p>
-            <a:pPr>
-              <a:defRPr sz="1800"/>
-            </a:pPr>
-            <a:r>
-              <a:t>Docker support added for reproducible deployment.</a:t>
-            </a:r>
-          </a:p>
-          <a:p>
-            <a:pPr>
-              <a:defRPr sz="1800"/>
-            </a:pPr>
-            <a:r>
-              <a:t>Model artifacts load without retraining during demo.</a:t>
+              <a:rPr dirty="0"/>
+              <a:t>• Support explainable candidate evaluation</a:t>
             </a:r>
           </a:p>
         </p:txBody>
@@ -3767,7 +4215,7 @@
 </file>
 
 <file path=ppt/slides/slide7.xml><?xml version="1.0" encoding="utf-8"?>
-<p:sld xmlns:a="http://schemas.openxmlformats.org/drawingml/2006/main" xmlns:p="http://schemas.openxmlformats.org/presentationml/2006/main" xmlns:r="http://schemas.openxmlformats.org/officeDocument/2006/relationships">
+<p:sld xmlns:a="http://schemas.openxmlformats.org/drawingml/2006/main" xmlns:r="http://schemas.openxmlformats.org/officeDocument/2006/relationships" xmlns:p="http://schemas.openxmlformats.org/presentationml/2006/main">
   <p:cSld>
     <p:spTree>
       <p:nvGrpSpPr>
@@ -3775,80 +4223,41 @@
         <p:cNvGrpSpPr/>
         <p:nvPr/>
       </p:nvGrpSpPr>
-      <p:grpSpPr/>
-      <p:sp>
-        <p:nvSpPr>
-          <p:cNvPr id="2" name="Title 1"/>
-          <p:cNvSpPr>
-            <a:spLocks noGrp="1"/>
-          </p:cNvSpPr>
-          <p:nvPr>
-            <p:ph type="title"/>
-          </p:nvPr>
-        </p:nvSpPr>
-        <p:spPr/>
-        <p:txBody>
-          <a:bodyPr/>
-          <a:lstStyle/>
-          <a:p>
-            <a:r>
-              <a:t>Screenshots</a:t>
-            </a:r>
-          </a:p>
-        </p:txBody>
-      </p:sp>
-      <p:sp>
-        <p:nvSpPr>
-          <p:cNvPr id="3" name="Content Placeholder 2"/>
-          <p:cNvSpPr>
-            <a:spLocks noGrp="1"/>
-          </p:cNvSpPr>
-          <p:nvPr>
-            <p:ph idx="1"/>
-          </p:nvPr>
-        </p:nvSpPr>
-        <p:spPr/>
-        <p:txBody>
-          <a:bodyPr/>
-          <a:lstStyle/>
-          <a:p/>
-        </p:txBody>
-      </p:sp>
-    </p:spTree>
-  </p:cSld>
-  <p:clrMapOvr>
-    <a:masterClrMapping/>
-  </p:clrMapOvr>
-</p:sld>
-</file>
-
-<file path=ppt/slides/slide8.xml><?xml version="1.0" encoding="utf-8"?>
-<p:sld xmlns:a="http://schemas.openxmlformats.org/drawingml/2006/main" xmlns:p="http://schemas.openxmlformats.org/presentationml/2006/main" xmlns:r="http://schemas.openxmlformats.org/officeDocument/2006/relationships">
-  <p:cSld>
-    <p:spTree>
-      <p:nvGrpSpPr>
-        <p:cNvPr id="1" name=""/>
-        <p:cNvGrpSpPr/>
-        <p:nvPr/>
-      </p:nvGrpSpPr>
-      <p:grpSpPr/>
-      <p:sp>
-        <p:nvSpPr>
-          <p:cNvPr id="2" name="Title 1"/>
-          <p:cNvSpPr>
-            <a:spLocks noGrp="1"/>
-          </p:cNvSpPr>
-          <p:nvPr>
-            <p:ph type="title"/>
-          </p:nvPr>
-        </p:nvSpPr>
-        <p:spPr/>
-        <p:txBody>
-          <a:bodyPr/>
-          <a:lstStyle/>
-          <a:p>
-            <a:r>
-              <a:t>01 Application Homepage</a:t>
+      <p:grpSpPr>
+        <a:xfrm>
+          <a:off x="0" y="0"/>
+          <a:ext cx="0" cy="0"/>
+          <a:chOff x="0" y="0"/>
+          <a:chExt cx="0" cy="0"/>
+        </a:xfrm>
+      </p:grpSpPr>
+      <p:sp>
+        <p:nvSpPr>
+          <p:cNvPr id="2" name="TextBox 1"/>
+          <p:cNvSpPr txBox="1"/>
+          <p:nvPr/>
+        </p:nvSpPr>
+        <p:spPr>
+          <a:xfrm>
+            <a:off x="457200" y="274320"/>
+            <a:ext cx="8229600" cy="731520"/>
+          </a:xfrm>
+          <a:prstGeom prst="rect">
+            <a:avLst/>
+          </a:prstGeom>
+          <a:noFill/>
+        </p:spPr>
+        <p:txBody>
+          <a:bodyPr wrap="none">
+            <a:spAutoFit/>
+          </a:bodyPr>
+          <a:lstStyle/>
+          <a:p>
+            <a:pPr>
+              <a:defRPr sz="4000" b="1"/>
+            </a:pPr>
+            <a:r>
+              <a:t>App Demo Screenshots</a:t>
             </a:r>
           </a:p>
         </p:txBody>
@@ -3869,8 +4278,32 @@
         </p:blipFill>
         <p:spPr>
           <a:xfrm>
-            <a:off x="457200" y="1371600"/>
-            <a:ext cx="8738075" cy="4572000"/>
+            <a:off x="457199" y="1097280"/>
+            <a:ext cx="7499024" cy="2428345"/>
+          </a:xfrm>
+          <a:prstGeom prst="rect">
+            <a:avLst/>
+          </a:prstGeom>
+        </p:spPr>
+      </p:pic>
+      <p:pic>
+        <p:nvPicPr>
+          <p:cNvPr id="4" name="Picture 3" descr="02_candidate_ranking_results.png"/>
+          <p:cNvPicPr>
+            <a:picLocks noChangeAspect="1"/>
+          </p:cNvPicPr>
+          <p:nvPr/>
+        </p:nvPicPr>
+        <p:blipFill>
+          <a:blip r:embed="rId3"/>
+          <a:stretch>
+            <a:fillRect/>
+          </a:stretch>
+        </p:blipFill>
+        <p:spPr>
+          <a:xfrm>
+            <a:off x="731519" y="3774493"/>
+            <a:ext cx="6809923" cy="2011760"/>
           </a:xfrm>
           <a:prstGeom prst="rect">
             <a:avLst/>
@@ -3885,8 +4318,8 @@
 </p:sld>
 </file>
 
-<file path=ppt/slides/slide9.xml><?xml version="1.0" encoding="utf-8"?>
-<p:sld xmlns:a="http://schemas.openxmlformats.org/drawingml/2006/main" xmlns:p="http://schemas.openxmlformats.org/presentationml/2006/main" xmlns:r="http://schemas.openxmlformats.org/officeDocument/2006/relationships">
+<file path=ppt/slides/slide8.xml><?xml version="1.0" encoding="utf-8"?>
+<p:sld xmlns:a="http://schemas.openxmlformats.org/drawingml/2006/main" xmlns:r="http://schemas.openxmlformats.org/officeDocument/2006/relationships" xmlns:p="http://schemas.openxmlformats.org/presentationml/2006/main">
   <p:cSld>
     <p:spTree>
       <p:nvGrpSpPr>
@@ -3894,52 +4327,120 @@
         <p:cNvGrpSpPr/>
         <p:nvPr/>
       </p:nvGrpSpPr>
-      <p:grpSpPr/>
-      <p:sp>
-        <p:nvSpPr>
-          <p:cNvPr id="2" name="Title 1"/>
-          <p:cNvSpPr>
-            <a:spLocks noGrp="1"/>
-          </p:cNvSpPr>
-          <p:nvPr>
-            <p:ph type="title"/>
-          </p:nvPr>
-        </p:nvSpPr>
-        <p:spPr/>
-        <p:txBody>
-          <a:bodyPr/>
-          <a:lstStyle/>
-          <a:p>
-            <a:r>
-              <a:t>02 Candidate Ranking Results</a:t>
-            </a:r>
-          </a:p>
-        </p:txBody>
-      </p:sp>
-      <p:pic>
-        <p:nvPicPr>
-          <p:cNvPr id="3" name="Picture 2" descr="02_candidate_ranking_results.png"/>
-          <p:cNvPicPr>
-            <a:picLocks noChangeAspect="1"/>
-          </p:cNvPicPr>
+      <p:grpSpPr>
+        <a:xfrm>
+          <a:off x="0" y="0"/>
+          <a:ext cx="0" cy="0"/>
+          <a:chOff x="0" y="0"/>
+          <a:chExt cx="0" cy="0"/>
+        </a:xfrm>
+      </p:grpSpPr>
+      <p:sp>
+        <p:nvSpPr>
+          <p:cNvPr id="2" name="TextBox 1"/>
+          <p:cNvSpPr txBox="1"/>
           <p:nvPr/>
-        </p:nvPicPr>
-        <p:blipFill>
-          <a:blip r:embed="rId2"/>
-          <a:stretch>
-            <a:fillRect/>
-          </a:stretch>
-        </p:blipFill>
+        </p:nvSpPr>
         <p:spPr>
           <a:xfrm>
-            <a:off x="457200" y="1371600"/>
-            <a:ext cx="15476483" cy="4572000"/>
+            <a:off x="457200" y="274320"/>
+            <a:ext cx="8229600" cy="731520"/>
           </a:xfrm>
           <a:prstGeom prst="rect">
             <a:avLst/>
           </a:prstGeom>
+          <a:noFill/>
         </p:spPr>
-      </p:pic>
+        <p:txBody>
+          <a:bodyPr wrap="none">
+            <a:spAutoFit/>
+          </a:bodyPr>
+          <a:lstStyle/>
+          <a:p>
+            <a:pPr>
+              <a:defRPr sz="4000" b="1"/>
+            </a:pPr>
+            <a:r>
+              <a:t>Impact &amp; Next Steps</a:t>
+            </a:r>
+          </a:p>
+        </p:txBody>
+      </p:sp>
+      <p:sp>
+        <p:nvSpPr>
+          <p:cNvPr id="3" name="TextBox 2"/>
+          <p:cNvSpPr txBox="1"/>
+          <p:nvPr/>
+        </p:nvSpPr>
+        <p:spPr>
+          <a:xfrm>
+            <a:off x="457200" y="1252823"/>
+            <a:ext cx="8229600" cy="1538883"/>
+          </a:xfrm>
+          <a:prstGeom prst="rect">
+            <a:avLst/>
+          </a:prstGeom>
+          <a:noFill/>
+        </p:spPr>
+        <p:txBody>
+          <a:bodyPr wrap="square">
+            <a:spAutoFit/>
+          </a:bodyPr>
+          <a:lstStyle/>
+          <a:p>
+            <a:pPr>
+              <a:defRPr sz="2000">
+                <a:solidFill>
+                  <a:srgbClr val="1A2A55"/>
+                </a:solidFill>
+              </a:defRPr>
+            </a:pPr>
+            <a:r>
+              <a:rPr dirty="0"/>
+              <a:t>This solution helps recruiters screen resumes faster with transparent candidate recommendations.</a:t>
+            </a:r>
+          </a:p>
+          <a:p>
+            <a:pPr lvl="1">
+              <a:defRPr sz="1800">
+                <a:solidFill>
+                  <a:srgbClr val="114D95"/>
+                </a:solidFill>
+              </a:defRPr>
+            </a:pPr>
+            <a:r>
+              <a:rPr dirty="0"/>
+              <a:t>• Faster hiring decisions</a:t>
+            </a:r>
+          </a:p>
+          <a:p>
+            <a:pPr lvl="1">
+              <a:defRPr sz="1800">
+                <a:solidFill>
+                  <a:srgbClr val="114D95"/>
+                </a:solidFill>
+              </a:defRPr>
+            </a:pPr>
+            <a:r>
+              <a:rPr dirty="0"/>
+              <a:t>• Explainable candidate fit</a:t>
+            </a:r>
+          </a:p>
+          <a:p>
+            <a:pPr lvl="1">
+              <a:defRPr sz="1800">
+                <a:solidFill>
+                  <a:srgbClr val="114D95"/>
+                </a:solidFill>
+              </a:defRPr>
+            </a:pPr>
+            <a:r>
+              <a:rPr dirty="0"/>
+              <a:t>• Future: richer resume parsing, improved UI, more skill coverage</a:t>
+            </a:r>
+          </a:p>
+        </p:txBody>
+      </p:sp>
     </p:spTree>
   </p:cSld>
   <p:clrMapOvr>

</xml_diff>